<commit_message>
docs: publish reviewed beginner workshop materials
</commit_message>
<xml_diff>
--- a/docs/workshop-slides.pptx
+++ b/docs/workshop-slides.pptx
@@ -618,7 +618,7 @@
 worked_example: Ready → dispense → belt to pickup endpoint → inspect. In simulation each command changes a model; no physical object is verified.
 predict: Which message appears first? Where should the object model stop?
 change: Change Ready to your pair name. Add repeat 2 around a message, then around one tested short sequence.
-run: Open local Blockly simulation; select this mission; run the starter once. Use STOP and Reset before a different test. Save your workspace.
+run: Open local Blockly simulation; select this mission; run the starter once. Use STOP and **Reset simulation** before a different test. Save your workspace.
 observe: Read the command log and model state. Compare the repeated messages with your prediction.
 explain: Why do instruction order and a stopped belt matter before pickup?
 success: Your pair can trace the order, predict a repeat count and explain one corrected sequence.
@@ -919,7 +919,7 @@
 predict: What greeting and how many object lines will appear?
 change: Change TEAM, predict, run. Then change REPEATS to 2, predict, run. Keep indentation.
 run: Open the Student notebook, save a pair copy and run cells from the top with Shift+Enter. Run the shared Program example in simulation.
-observe: Count output lines and compare the shared Python program JSON with the Blockly exported JSON.
+observe: Count output lines. Open **View executable Python** in Blockly and compare the command rows in its `program` list with `program.program` in the shared Python example. JSON is text that stores the instruction list. **Save blocks** saves the workspace to reopen the editor; it is a different file.
 explain: Which edit changed text? Which changed how often a line ran? What stayed in the same order?
 success: Both partners make one edit and explain it; shared commands are validated before execution.
 offline_route: Run exercises/01_python.py using the prepared Python or trace it on paper. No package downloads.
@@ -1019,7 +1019,7 @@
 predict: What greeting and how many object lines will appear?
 change: Change TEAM, predict, run. Then change REPEATS to 2, predict, run. Keep indentation.
 run: Open the Student notebook, save a pair copy and run cells from the top with Shift+Enter. Run the shared Program example in simulation.
-observe: Count output lines and compare the shared Python program JSON with the Blockly exported JSON.
+observe: Count output lines. Open **View executable Python** in Blockly and compare the command rows in its `program` list with `program.program` in the shared Python example. JSON is text that stores the instruction list. **Save blocks** saves the workspace to reopen the editor; it is a different file.
 explain: Which edit changed text? Which changed how often a line ran? What stayed in the same order?
 success: Both partners make one edit and explain it; shared commands are validated before execution.
 offline_route: Run exercises/01_python.py using the prepared Python or trace it on paper. No package downloads.
@@ -1315,7 +1315,7 @@
             <a:r>
               <a:rPr lang="en-US" dirty="0"/>
               <a:t>45 minute activity. These two cards share that one activity duration.
-worked_example: Three pairs rotate through arm/twin observation, conveyor/observation sequencing, and offline Blockly/Python preparation.
+worked_example: Completed SIMULATION sample using the earlier invented joint calculation: our prediction was 35° relative. We changed LEADER_NOW from 10° to 15°, keeping LEADER_START = 10° and FOLLOWER_START = 30°. The model calculation 30 + 15 - 10 printed 35° relative and 15° absolute. This is arithmetic, not a measured physical joint or evidence of safe motion. For arm observation use the existing Teach demo example (Watch teach inspect return replay) and Live notebook. For conveyor reports use the Observe and decide example (Separate the object from its report). For offline preparation use the shared Program example under Change a name and a number.
 predict: At your current station, predict one direction, report or sequence before the instructor or simulator acts.
 change: Change only one paper angle, report or message; switch driver and observer halfway.
 run: Each slot is 15 minutes: 2 predict, 7 change/run, 4 observe/explain, 2 save and transition. Use the rotation table.
@@ -1415,7 +1415,7 @@
             <a:r>
               <a:rPr lang="en-US" dirty="0"/>
               <a:t>45 minute activity. These two cards share that one activity duration.
-worked_example: Three pairs rotate through arm/twin observation, conveyor/observation sequencing, and offline Blockly/Python preparation.
+worked_example: Completed SIMULATION sample using the earlier invented joint calculation: our prediction was 35° relative. We changed LEADER_NOW from 10° to 15°, keeping LEADER_START = 10° and FOLLOWER_START = 30°. The model calculation 30 + 15 - 10 printed 35° relative and 15° absolute. This is arithmetic, not a measured physical joint or evidence of safe motion. For arm observation use the existing Teach demo example (Watch teach inspect return replay) and Live notebook. For conveyor reports use the Observe and decide example (Separate the object from its report). For offline preparation use the shared Program example under Change a name and a number.
 predict: At your current station, predict one direction, report or sequence before the instructor or simulator acts.
 change: Change only one paper angle, report or message; switch driver and observer halfway.
 run: Each slot is 15 minutes: 2 predict, 7 change/run, 4 observe/explain, 2 save and transition. Use the rotation table.
@@ -2004,7 +2004,7 @@
             <a:r>
               <a:rPr lang="en-US" dirty="0"/>
               <a:t>10 minute activity. These two cards share that one activity duration.
-worked_example: Pair A shows prediction, one change, observed result and one limit; then pairs B and C follow.
+worked_example: Completed SIMULATION sample from the earlier Blockly message exercise: we predicted Ready would appear twice. We changed the repeat count from 1 to 2 around the Ready message. The simulated command log showed Ready twice. This checks message repetition only; it does not prove physical conveyor arrival or a grasp.
 predict: Which single output best supports your claim?
 change: Shorten your demonstration to one change and one observation.
 run: Use 1 minute preparation, 3 demonstrations of 2 minutes, 3 minutes shared reflection. Both partners speak.
@@ -2104,7 +2104,7 @@
             <a:r>
               <a:rPr lang="en-US" dirty="0"/>
               <a:t>10 minute activity. These two cards share that one activity duration.
-worked_example: Pair A shows prediction, one change, observed result and one limit; then pairs B and C follow.
+worked_example: Completed SIMULATION sample from the earlier Blockly message exercise: we predicted Ready would appear twice. We changed the repeat count from 1 to 2 around the Ready message. The simulated command log showed Ready twice. This checks message repetition only; it does not prove physical conveyor arrival or a grasp.
 predict: Which single output best supports your claim?
 change: Shorten your demonstration to one change and one observation.
 run: Use 1 minute preparation, 3 demonstrations of 2 minutes, 3 minutes shared reflection. Both partners speak.
@@ -2741,7 +2741,7 @@
 worked_example: Ready → dispense → belt to pickup endpoint → inspect. In simulation each command changes a model; no physical object is verified.
 predict: Which message appears first? Where should the object model stop?
 change: Change Ready to your pair name. Add repeat 2 around a message, then around one tested short sequence.
-run: Open local Blockly simulation; select this mission; run the starter once. Use STOP and Reset before a different test. Save your workspace.
+run: Open local Blockly simulation; select this mission; run the starter once. Use STOP and **Reset simulation** before a different test. Save your workspace.
 observe: Read the command log and model state. Compare the repeated messages with your prediction.
 explain: Why do instruction order and a stopped belt matter before pickup?
 success: Your pair can trace the order, predict a repeat count and explain one corrected sequence.
@@ -5362,7 +5362,7 @@
                 <a:ea typeface="Liberation Sans" pitchFamily="34" charset="-122"/>
                 <a:cs typeface="Liberation Sans" pitchFamily="34" charset="-120"/>
               </a:rPr>
-              <a:t>Count lines. Compare Program JSON with the Blockly export.</a:t>
+              <a:t>Count lines. Compare program.program command rows with the program list in View executable Python.</a:t>
             </a:r>
             <a:endParaRPr lang="en-US" sz="2400" dirty="0"/>
           </a:p>
@@ -6740,7 +6740,7 @@
                 <a:ea typeface="Liberation Sans" pitchFamily="34" charset="-122"/>
                 <a:cs typeface="Liberation Sans" pitchFamily="34" charset="-120"/>
               </a:rPr>
-              <a:t>Three pairs: arm/twin; conveyor/observations; offline preparation.</a:t>
+              <a:t>SIMULATION: changed leader now 10°→15°; predicted and calculated relative 30 + 15 - 10 = 35°. No physical joint was measured.</a:t>
             </a:r>
             <a:endParaRPr lang="en-US" sz="2400" dirty="0"/>
           </a:p>
@@ -9910,7 +9910,7 @@
                 <a:ea typeface="Liberation Sans" pitchFamily="34" charset="-122"/>
                 <a:cs typeface="Liberation Sans" pitchFamily="34" charset="-120"/>
               </a:rPr>
-              <a:t>Show prediction, one change, observed result and one limit.</a:t>
+              <a:t>SIMULATION: repeat count 1→2. Predicted Ready twice; log showed Ready twice. This checks messages, not physical arrival or grasp.</a:t>
             </a:r>
             <a:endParaRPr lang="en-US" sz="2400" dirty="0"/>
           </a:p>
@@ -12889,7 +12889,7 @@
                 <a:ea typeface="Liberation Sans" pitchFamily="34" charset="-122"/>
                 <a:cs typeface="Liberation Sans" pitchFamily="34" charset="-120"/>
               </a:rPr>
-              <a:t>Run the local Blockly starter once. Reset between experiments.</a:t>
+              <a:t>Run the local Blockly starter once. Use Reset simulation between experiments.</a:t>
             </a:r>
             <a:endParaRPr lang="en-US" sz="2400" dirty="0"/>
           </a:p>

</xml_diff>

<commit_message>
fix(workshop): align beginner instructions and generated materials
Match the Blockly/Python starter, introduce teaching vocabulary before use and provide actual paper observation inputs. Preserve document images while projecting plain browser text and restore a real slide prediction prompt. Regenerated materials pass independent scoped review, 65 focused tests, three fresh notebooks, manifest/ZIP and changed-render checks. Durable evidence SHA256: 198c3720b34a45ec8260f6c39bac3786cbaf9d9c79a26f7295df44b4e8cfabf9. Physical rehearsal and main release remain open.
</commit_message>
<xml_diff>
--- a/docs/workshop-slides.pptx
+++ b/docs/workshop-slides.pptx
@@ -715,14 +715,15 @@
             <a:r>
               <a:rPr lang="en-US" dirty="0"/>
               <a:t>20 minute activity. These two cards share that one activity duration.
-worked_example: An actual blue brick can have a missing report. An actual red brick can be reported blue. Both need inspection.
+worked_example: Use the human-labelled real photo collage notebooks/assets/photo-examples.jpg (also printed in the Student handbook under Separate the object from its report). Human labels describe visible objects. These reports are deliberately invented, not camera measurements. Row 1: actual red, report red. Row 2: actual blue, report None (missing). Row 3: actual red, report blue.
+![Human-labelled real photo crops; reports are deliberately invented](../notebooks/assets/photo-examples.jpg)
 predict: Which of the three reports is missing? Which disagrees with the labelled object?
 change: Change one report to None; then change one known report to a wrong known color.
-run: Run the short Python example or trace its three rows on paper. Compare the real labelled photo with a deliberately changed report.
+run: Run the short Python example or trace these three rows on paper. Compare the human-labelled red/blue crops in notebooks/assets/photo-examples.jpg, also printed in the Student handbook under Separate the object from its report, with the invented reports.
 observe: Record actual object, reported label and your decision separately. None means missing, never zero or proof of empty space.
 explain: Why can a fresh color label still be wrong? What evidence would justify continuing?
 success: You identify one missing and one wrong report and choose pause/inspect for uncertainty.
-offline_route: Use the supplied real photo and handwritten report cards; no camera or website is needed.
+offline_route: Paper pair: use the Student handbook's printed collage under Separate the object from its report, or open notebooks/assets/photo-examples.jpg from the learner ZIP. Use the three actual/report rows above and on your worksheet. These are human-visible labels with deliberately invented reports, not camera measurements.
 extension: Test unfamiliar green without adding a rule.
 Compare actual and reported columns one row at a time.
 A known word is still only a report.
@@ -815,14 +816,15 @@
             <a:r>
               <a:rPr lang="en-US" dirty="0"/>
               <a:t>20 minute activity. These two cards share that one activity duration.
-worked_example: An actual blue brick can have a missing report. An actual red brick can be reported blue. Both need inspection.
+worked_example: Use the human-labelled real photo collage notebooks/assets/photo-examples.jpg (also printed in the Student handbook under Separate the object from its report). Human labels describe visible objects. These reports are deliberately invented, not camera measurements. Row 1: actual red, report red. Row 2: actual blue, report None (missing). Row 3: actual red, report blue.
+![Human-labelled real photo crops; reports are deliberately invented](../notebooks/assets/photo-examples.jpg)
 predict: Which of the three reports is missing? Which disagrees with the labelled object?
 change: Change one report to None; then change one known report to a wrong known color.
-run: Run the short Python example or trace its three rows on paper. Compare the real labelled photo with a deliberately changed report.
+run: Run the short Python example or trace these three rows on paper. Compare the human-labelled red/blue crops in notebooks/assets/photo-examples.jpg, also printed in the Student handbook under Separate the object from its report, with the invented reports.
 observe: Record actual object, reported label and your decision separately. None means missing, never zero or proof of empty space.
 explain: Why can a fresh color label still be wrong? What evidence would justify continuing?
 success: You identify one missing and one wrong report and choose pause/inspect for uncertainty.
-offline_route: Use the supplied real photo and handwritten report cards; no camera or website is needed.
+offline_route: Paper pair: use the Student handbook's printed collage under Separate the object from its report, or open notebooks/assets/photo-examples.jpg from the learner ZIP. Use the three actual/report rows above and on your worksheet. These are human-visible labels with deliberately invented reports, not camera measurements.
 extension: Test unfamiliar green without adding a rule.
 Compare actual and reported columns one row at a time.
 A known word is still only a report.
@@ -918,8 +920,8 @@
 worked_example: TEAM stores text in quotes. REPEATS stores a number. print shows text. The indented line runs once for each number.
 predict: What greeting and how many object lines will appear?
 change: Change TEAM, predict, run. Then change REPEATS to 2, predict, run. Keep indentation.
-run: Open the Student notebook, save a pair copy and run cells from the top with Shift+Enter. Run the shared Program example in simulation.
-observe: Count output lines. Open **View executable Python** in Blockly and compare the command rows in its `program` list with `program.program` in the shared Python example. JSON is text that stores the instruction list. **Save blocks** saves the workspace to reopen the editor; it is a different file.
+run: Open the Student notebook, save a pair copy and run from the top with Shift+Enter. Run the shared Program example in simulation. In Blockly choose "Change a name and a number" before View executable Python.
+observe: Count output lines. In Blockly choose "Change a name and a number", then **View executable Python**. Compare the command rows in its `program` list with `program.program` in the shared Python example: Ready, eject, left_end. JSON is text that stores the instruction list. **Save blocks** saves the workspace to reopen the editor; it is a different file. Simulation only.
 explain: Which edit changed text? Which changed how often a line ran? What stayed in the same order?
 success: Both partners make one edit and explain it; shared commands are validated before execution.
 offline_route: Run exercises/01_python.py using the prepared Python or trace it on paper. No package downloads.
@@ -1018,8 +1020,8 @@
 worked_example: TEAM stores text in quotes. REPEATS stores a number. print shows text. The indented line runs once for each number.
 predict: What greeting and how many object lines will appear?
 change: Change TEAM, predict, run. Then change REPEATS to 2, predict, run. Keep indentation.
-run: Open the Student notebook, save a pair copy and run cells from the top with Shift+Enter. Run the shared Program example in simulation.
-observe: Count output lines. Open **View executable Python** in Blockly and compare the command rows in its `program` list with `program.program` in the shared Python example. JSON is text that stores the instruction list. **Save blocks** saves the workspace to reopen the editor; it is a different file.
+run: Open the Student notebook, save a pair copy and run from the top with Shift+Enter. Run the shared Program example in simulation. In Blockly choose "Change a name and a number" before View executable Python.
+observe: Count output lines. In Blockly choose "Change a name and a number", then **View executable Python**. Compare the command rows in its `program` list with `program.program` in the shared Python example: Ready, eject, left_end. JSON is text that stores the instruction list. **Save blocks** saves the workspace to reopen the editor; it is a different file. Simulation only.
 explain: Which edit changed text? Which changed how often a line ran? What stayed in the same order?
 success: Both partners make one edit and explain it; shared commands are validated before execution.
 offline_route: Run exercises/01_python.py using the prepared Python or trace it on paper. No package downloads.
@@ -1115,10 +1117,10 @@
             <a:r>
               <a:rPr lang="en-US" dirty="0"/>
               <a:t>15 minute activity. These two cards share that one activity duration.
-worked_example: Leader 10°, follower 30°, leader now 15° gives relative request 35°. A request and a measured result are different.
+worked_example: A stroke is one saved movement. A pose is the arm arrangement at start/end. Jaw state means gripper opening. Calibration means the measured references a recording assumes. Metadata means recording details. Relative follows the change from each arm's starting angle: leader starts at 10°, follower at 30°, leader now 15°, so follower requests 30 + (15 - 10) = 35°. Absolute uses the leader's calibrated angle, 15°. These are invented DEMO angles. A request and a measured result are different.
 predict: Will a replay start safely from any pose? What if the jaw state changed?
 change: Ask the instructor to change one invented angle; predict before rerunning. Learners do not change physical modes.
-run: Watch instructor: teach a short empty stroke, stop recording, inspect metadata and path, return safely to its validated start, then replay separately.
+run: Watch instructor: teach a short empty stroke, stop recording, inspect recording details and path, return safely to its validated start, then replay separately.
 observe: Name start pose, endpoint, jaw state, identity/calibration and validity evidence. An invented demo recording is never a student-taught physical skill.
 explain: Why must teaching and playback be separate runs? Why does a changed robot or calibration require reteaching?
 success: You can say teach → inspect/validate → return to start → replay, and point to STOP.
@@ -1126,7 +1128,7 @@
 extension: Predict a relative versus absolute joint request.
 A recording stores movement; it does not plan a safe approach from every pose.
 A screen model can match commands while a physical object slips.
-Instructor: Relative is 35 and absolute 15. Demonstrate only with prepared supervised hardware; if validation fails use paper and report physical gate incomplete.</a:t>
+Instructor: Before the demonstration define stroke, pose, jaw state and calibration as above. Relative follows each arm's starting angle plus the leader's change; absolute uses the leader's calibrated angle. Demonstrate only with prepared supervised hardware; if validation fails use paper and report physical gate incomplete.</a:t>
             </a:r>
             <a:endParaRPr lang="en-US" dirty="0"/>
           </a:p>
@@ -1215,10 +1217,10 @@
             <a:r>
               <a:rPr lang="en-US" dirty="0"/>
               <a:t>15 minute activity. These two cards share that one activity duration.
-worked_example: Leader 10°, follower 30°, leader now 15° gives relative request 35°. A request and a measured result are different.
+worked_example: A stroke is one saved movement. A pose is the arm arrangement at start/end. Jaw state means gripper opening. Calibration means the measured references a recording assumes. Metadata means recording details. Relative follows the change from each arm's starting angle: leader starts at 10°, follower at 30°, leader now 15°, so follower requests 30 + (15 - 10) = 35°. Absolute uses the leader's calibrated angle, 15°. These are invented DEMO angles. A request and a measured result are different.
 predict: Will a replay start safely from any pose? What if the jaw state changed?
 change: Ask the instructor to change one invented angle; predict before rerunning. Learners do not change physical modes.
-run: Watch instructor: teach a short empty stroke, stop recording, inspect metadata and path, return safely to its validated start, then replay separately.
+run: Watch instructor: teach a short empty stroke, stop recording, inspect recording details and path, return safely to its validated start, then replay separately.
 observe: Name start pose, endpoint, jaw state, identity/calibration and validity evidence. An invented demo recording is never a student-taught physical skill.
 explain: Why must teaching and playback be separate runs? Why does a changed robot or calibration require reteaching?
 success: You can say teach → inspect/validate → return to start → replay, and point to STOP.
@@ -1226,7 +1228,7 @@
 extension: Predict a relative versus absolute joint request.
 A recording stores movement; it does not plan a safe approach from every pose.
 A screen model can match commands while a physical object slips.
-Instructor: Relative is 35 and absolute 15. Demonstrate only with prepared supervised hardware; if validation fails use paper and report physical gate incomplete.</a:t>
+Instructor: Before the demonstration define stroke, pose, jaw state and calibration as above. Relative follows each arm's starting angle plus the leader's change; absolute uses the leader's calibrated angle. Demonstrate only with prepared supervised hardware; if validation fails use paper and report physical gate incomplete.</a:t>
             </a:r>
             <a:endParaRPr lang="en-US" dirty="0"/>
           </a:p>
@@ -2649,7 +2651,7 @@
             <a:r>
               <a:rPr lang="en-US" dirty="0"/>
               <a:t>2 minutes
-Swap pair driver/observer. Point to STOP. Physical execution requires the instructor and prepared verified recordings. Begin the first local mission.</a:t>
+A stroke is one saved movement. A pose is the arm arrangement at start/end. Jaw state means gripper opening. Calibration means the measured references a recording assumes. Metadata means recording details. First define these terms, then demonstrate teach, stop recording, inspect/validate, return to the validated start, and replay separately. A recording does not plan a safe approach from any pose. Swap pair driver/observer. Point to STOP. Physical execution requires the instructor and prepared verified recordings. Begin the first local mission.</a:t>
             </a:r>
             <a:endParaRPr lang="en-US" dirty="0"/>
           </a:p>
@@ -4040,7 +4042,7 @@
                 <a:ea typeface="Liberation Sans" pitchFamily="34" charset="-122"/>
                 <a:cs typeface="Liberation Sans" pitchFamily="34" charset="-120"/>
               </a:rPr>
-              <a:t>Actual blue + missing report: pause. Actual red + blue report: inspect.</a:t>
+              <a:t>Actual/report (invented reports): 1 red/red; 2 blue/None; 3 red/blue.</a:t>
             </a:r>
             <a:endParaRPr lang="en-US" sz="2400" dirty="0"/>
           </a:p>
@@ -4274,7 +4276,7 @@
                 <a:ea typeface="Liberation Sans" pitchFamily="34" charset="-122"/>
                 <a:cs typeface="Liberation Sans" pitchFamily="34" charset="-120"/>
               </a:rPr>
-              <a:t>Run or trace the three rows. Use the supplied labelled photograph.</a:t>
+              <a:t>Human-labelled photo: handbook, observation mission; ZIP notebooks/assets/photo-examples.jpg. Reports invented.</a:t>
             </a:r>
             <a:endParaRPr lang="en-US" sz="2400" dirty="0"/>
           </a:p>
@@ -5174,7 +5176,7 @@
                 <a:ea typeface="Liberation Sans" pitchFamily="34" charset="-122"/>
                 <a:cs typeface="Liberation Sans" pitchFamily="34" charset="-120"/>
               </a:rPr>
-              <a:t>Save a pair notebook copy; run from the top with Shift+Enter.</a:t>
+              <a:t>Run notebook from the top. In Blockly choose "Change a name and a number", then View executable Python. Simulation only.</a:t>
             </a:r>
             <a:endParaRPr lang="en-US" sz="2400" dirty="0"/>
           </a:p>
@@ -5362,7 +5364,7 @@
                 <a:ea typeface="Liberation Sans" pitchFamily="34" charset="-122"/>
                 <a:cs typeface="Liberation Sans" pitchFamily="34" charset="-120"/>
               </a:rPr>
-              <a:t>Count lines. Compare program.program command rows with the program list in View executable Python.</a:t>
+              <a:t>In "Change a name and a number", use View executable Python. Compare its rows with program.program.</a:t>
             </a:r>
             <a:endParaRPr lang="en-US" sz="2400" dirty="0"/>
           </a:p>
@@ -5840,7 +5842,7 @@
                 <a:ea typeface="Liberation Sans" pitchFamily="34" charset="-122"/>
                 <a:cs typeface="Liberation Sans" pitchFamily="34" charset="-120"/>
               </a:rPr>
-              <a:t>Leader 10°, follower 30°, leader now 15°: relative request 35°.</a:t>
+              <a:t>Stroke: one saved movement. Pose: start/end arrangement. Jaw state: gripper opening. Calibration: measured references.</a:t>
             </a:r>
             <a:endParaRPr lang="en-US" sz="2400" dirty="0"/>
           </a:p>
@@ -5918,7 +5920,7 @@
                 <a:ea typeface="Liberation Sans" pitchFamily="34" charset="-122"/>
                 <a:cs typeface="Liberation Sans" pitchFamily="34" charset="-120"/>
               </a:rPr>
-              <a:t>Can replay begin from any pose? What if the jaw state changed?</a:t>
+              <a:t>Will a replay start safely from any pose? What if the jaw state changed?</a:t>
             </a:r>
             <a:endParaRPr lang="en-US" sz="2400" dirty="0"/>
           </a:p>
@@ -6074,7 +6076,7 @@
                 <a:ea typeface="Liberation Sans" pitchFamily="34" charset="-122"/>
                 <a:cs typeface="Liberation Sans" pitchFamily="34" charset="-120"/>
               </a:rPr>
-              <a:t>Watch: teach, stop recording, inspect, return to validated start, replay.</a:t>
+              <a:t>Instructor: teach, stop recording, inspect recording details/path, return to validated start, then replay separately. Locate STOP.</a:t>
             </a:r>
             <a:endParaRPr lang="en-US" sz="2400" dirty="0"/>
           </a:p>
@@ -12350,7 +12352,7 @@
                 <a:ea typeface="Liberation Sans" pitchFamily="34" charset="-122"/>
                 <a:cs typeface="Liberation Sans" pitchFamily="34" charset="-120"/>
               </a:rPr>
-              <a:t>Teach a short stroke</a:t>
+              <a:t>Stroke: one saved movement</a:t>
             </a:r>
             <a:endParaRPr lang="en-US" sz="2800" dirty="0"/>
           </a:p>
@@ -12389,7 +12391,7 @@
                 <a:ea typeface="Liberation Sans" pitchFamily="34" charset="-122"/>
                 <a:cs typeface="Liberation Sans" pitchFamily="34" charset="-120"/>
               </a:rPr>
-              <a:t>Inspect and validate</a:t>
+              <a:t>Pose: arm arrangement at start/end</a:t>
             </a:r>
             <a:endParaRPr lang="en-US" sz="2800" dirty="0"/>
           </a:p>
@@ -12428,7 +12430,7 @@
                 <a:ea typeface="Liberation Sans" pitchFamily="34" charset="-122"/>
                 <a:cs typeface="Liberation Sans" pitchFamily="34" charset="-120"/>
               </a:rPr>
-              <a:t>Return to the validated start</a:t>
+              <a:t>Jaw state: gripper opening</a:t>
             </a:r>
             <a:endParaRPr lang="en-US" sz="2800" dirty="0"/>
           </a:p>
@@ -12467,7 +12469,7 @@
                 <a:ea typeface="Liberation Sans" pitchFamily="34" charset="-122"/>
                 <a:cs typeface="Liberation Sans" pitchFamily="34" charset="-120"/>
               </a:rPr>
-              <a:t>Replay separately</a:t>
+              <a:t>Calibration: measured references</a:t>
             </a:r>
             <a:endParaRPr lang="en-US" sz="2800" dirty="0"/>
           </a:p>

</xml_diff>